<commit_message>
Audit clinical text and symbols; clarify density units, comparisons, age and follow-up wording
</commit_message>
<xml_diff>
--- a/outputs/ophthalmology-batch-20261011/endothelium/A4_bw_editable.pptx
+++ b/outputs/ophthalmology-batch-20261011/endothelium/A4_bw_editable.pptx
@@ -647,7 +647,7 @@
           <a:p/>
           <a:p>
             <a:r>
-              <a:t>endothelium-12 气体固定：过滤空气或10%~14% C3F8固定；气少/吸收快增脱离，过多致瞳孔阻滞。复杂DSEK可黏弹剂，DMEK不能黏弹剂固定。</a:t>
+              <a:t>endothelium-12 气体固定：过滤空气或10%~14% C₃F₈固定；气少/吸收快增脱离，过多致瞳孔阻滞。复杂DSEK可黏弹剂，DMEK不能使用黏弹剂固定植片。</a:t>
             </a:r>
           </a:p>
           <a:p>
@@ -759,7 +759,7 @@
           <a:p/>
           <a:p>
             <a:r>
-              <a:t>endothelium-16 阻滞性青光眼：推荐6:00周边虹膜切除防阻滞；术后早期2~6 h密切看眼压，必要时释过量前房气体，避免不可逆损伤。具体眼压数值切点未明确。</a:t>
+              <a:t>endothelium-16 阻滞性青光眼：推荐6点钟方位周边虹膜切除防阻滞；术后早期2~6 h密切看眼压，必要时释过量前房气体，避免不可逆损伤。具体眼压数值切点未明确。</a:t>
             </a:r>
           </a:p>
           <a:p>
@@ -791,7 +791,7 @@
           <a:p/>
           <a:p>
             <a:r>
-              <a:t>endothelium-18 术后检查：第1天气体填大部前房但坐位避开6:00虹膜切除口；可疑脱离及时前节OCT；透明后尽早内皮计数并定期复查。</a:t>
+              <a:t>endothelium-18 术后检查：第1天气体填大部前房但坐位避开6点钟方位虹膜切除口；可疑脱离及时前节OCT；透明后尽早内皮计数并定期复查。</a:t>
             </a:r>
           </a:p>
           <a:p>
@@ -4710,7 +4710,7 @@
       </p:sp>
       <p:sp>
         <p:nvSpPr>
-          <p:cNvPr id="19" name="辨方向、减少接触；空气或10%~14% C3F8固定；周边虹膜切除防阻滞。DMEK不能黏弹剂固定。"/>
+          <p:cNvPr id="19" name="辨方向、减少接触；空气或10%~14% C₃F₈固定；周边虹膜切除防阻滞。DMEK不能使用黏弹剂固定"/>
           <p:cNvSpPr txBox="1"/>
           <p:nvPr/>
         </p:nvSpPr>
@@ -4750,7 +4750,51 @@
                 <a:ea typeface="Microsoft YaHei"/>
                 <a:cs typeface="Microsoft YaHei"/>
               </a:rPr>
-              <a:t>辨方向、减少接触；空气或10%~14% C3F8固定；周边虹膜</a:t>
+              <a:t>辨方向、减少接触；空气或10%~14% C</a:t>
+            </a:r>
+            <a:r>
+              <a:rPr sz="950" b="0" lang="zh-CN">
+                <a:solidFill>
+                  <a:srgbClr val="000000"/>
+                </a:solidFill>
+                <a:latin typeface="Arial"/>
+                <a:ea typeface="Arial"/>
+                <a:cs typeface="Arial"/>
+              </a:rPr>
+              <a:t>₃</a:t>
+            </a:r>
+            <a:r>
+              <a:rPr sz="950" b="0" lang="zh-CN">
+                <a:solidFill>
+                  <a:srgbClr val="000000"/>
+                </a:solidFill>
+                <a:latin typeface="Microsoft YaHei"/>
+                <a:ea typeface="Microsoft YaHei"/>
+                <a:cs typeface="Microsoft YaHei"/>
+              </a:rPr>
+              <a:t>F</a:t>
+            </a:r>
+            <a:r>
+              <a:rPr sz="950" b="0" lang="zh-CN">
+                <a:solidFill>
+                  <a:srgbClr val="000000"/>
+                </a:solidFill>
+                <a:latin typeface="Arial"/>
+                <a:ea typeface="Arial"/>
+                <a:cs typeface="Arial"/>
+              </a:rPr>
+              <a:t>₈</a:t>
+            </a:r>
+            <a:r>
+              <a:rPr sz="950" b="0" lang="zh-CN">
+                <a:solidFill>
+                  <a:srgbClr val="000000"/>
+                </a:solidFill>
+                <a:latin typeface="Microsoft YaHei"/>
+                <a:ea typeface="Microsoft YaHei"/>
+                <a:cs typeface="Microsoft YaHei"/>
+              </a:rPr>
+              <a:t>固定；周边虹膜切</a:t>
             </a:r>
           </a:p>
           <a:p>
@@ -4774,7 +4818,7 @@
                 <a:ea typeface="Microsoft YaHei"/>
                 <a:cs typeface="Microsoft YaHei"/>
               </a:rPr>
-              <a:t>切除防阻滞。DMEK不能黏弹剂固定。</a:t>
+              <a:t>除防阻滞。DMEK不能使用黏弹剂固定。</a:t>
             </a:r>
           </a:p>
         </p:txBody>
@@ -5760,7 +5804,7 @@
       </p:sp>
       <p:sp>
         <p:nvSpPr>
-          <p:cNvPr id="39" name="辨方向、减少接触；空气或10%~14% C3F8固定；周边虹膜切除防阻滞。DMEK不能黏弹剂固定。"/>
+          <p:cNvPr id="39" name="辨方向、减少接触；空气或10%~14% C₃F₈固定；周边虹膜切除防阻滞。DMEK不能使用黏弹剂固定"/>
           <p:cNvSpPr txBox="1"/>
           <p:nvPr/>
         </p:nvSpPr>
@@ -5800,7 +5844,51 @@
                 <a:ea typeface="Microsoft YaHei"/>
                 <a:cs typeface="Microsoft YaHei"/>
               </a:rPr>
-              <a:t>辨方向、减少接触；空气或10%~14% C3F8固定；周边虹膜</a:t>
+              <a:t>辨方向、减少接触；空气或10%~14% C</a:t>
+            </a:r>
+            <a:r>
+              <a:rPr sz="950" b="0" lang="zh-CN">
+                <a:solidFill>
+                  <a:srgbClr val="000000"/>
+                </a:solidFill>
+                <a:latin typeface="Arial"/>
+                <a:ea typeface="Arial"/>
+                <a:cs typeface="Arial"/>
+              </a:rPr>
+              <a:t>₃</a:t>
+            </a:r>
+            <a:r>
+              <a:rPr sz="950" b="0" lang="zh-CN">
+                <a:solidFill>
+                  <a:srgbClr val="000000"/>
+                </a:solidFill>
+                <a:latin typeface="Microsoft YaHei"/>
+                <a:ea typeface="Microsoft YaHei"/>
+                <a:cs typeface="Microsoft YaHei"/>
+              </a:rPr>
+              <a:t>F</a:t>
+            </a:r>
+            <a:r>
+              <a:rPr sz="950" b="0" lang="zh-CN">
+                <a:solidFill>
+                  <a:srgbClr val="000000"/>
+                </a:solidFill>
+                <a:latin typeface="Arial"/>
+                <a:ea typeface="Arial"/>
+                <a:cs typeface="Arial"/>
+              </a:rPr>
+              <a:t>₈</a:t>
+            </a:r>
+            <a:r>
+              <a:rPr sz="950" b="0" lang="zh-CN">
+                <a:solidFill>
+                  <a:srgbClr val="000000"/>
+                </a:solidFill>
+                <a:latin typeface="Microsoft YaHei"/>
+                <a:ea typeface="Microsoft YaHei"/>
+                <a:cs typeface="Microsoft YaHei"/>
+              </a:rPr>
+              <a:t>固定；周边虹膜切</a:t>
             </a:r>
           </a:p>
           <a:p>
@@ -5824,7 +5912,7 @@
                 <a:ea typeface="Microsoft YaHei"/>
                 <a:cs typeface="Microsoft YaHei"/>
               </a:rPr>
-              <a:t>切除防阻滞。DMEK不能黏弹剂固定。</a:t>
+              <a:t>除防阻滞。DMEK不能使用黏弹剂固定。</a:t>
             </a:r>
           </a:p>
         </p:txBody>
@@ -6810,7 +6898,7 @@
       </p:sp>
       <p:sp>
         <p:nvSpPr>
-          <p:cNvPr id="59" name="辨方向、减少接触；空气或10%~14% C3F8固定；周边虹膜切除防阻滞。DMEK不能黏弹剂固定。"/>
+          <p:cNvPr id="59" name="辨方向、减少接触；空气或10%~14% C₃F₈固定；周边虹膜切除防阻滞。DMEK不能使用黏弹剂固定"/>
           <p:cNvSpPr txBox="1"/>
           <p:nvPr/>
         </p:nvSpPr>
@@ -6850,7 +6938,51 @@
                 <a:ea typeface="Microsoft YaHei"/>
                 <a:cs typeface="Microsoft YaHei"/>
               </a:rPr>
-              <a:t>辨方向、减少接触；空气或10%~14% C3F8固定；周边虹膜</a:t>
+              <a:t>辨方向、减少接触；空气或10%~14% C</a:t>
+            </a:r>
+            <a:r>
+              <a:rPr sz="950" b="0" lang="zh-CN">
+                <a:solidFill>
+                  <a:srgbClr val="000000"/>
+                </a:solidFill>
+                <a:latin typeface="Arial"/>
+                <a:ea typeface="Arial"/>
+                <a:cs typeface="Arial"/>
+              </a:rPr>
+              <a:t>₃</a:t>
+            </a:r>
+            <a:r>
+              <a:rPr sz="950" b="0" lang="zh-CN">
+                <a:solidFill>
+                  <a:srgbClr val="000000"/>
+                </a:solidFill>
+                <a:latin typeface="Microsoft YaHei"/>
+                <a:ea typeface="Microsoft YaHei"/>
+                <a:cs typeface="Microsoft YaHei"/>
+              </a:rPr>
+              <a:t>F</a:t>
+            </a:r>
+            <a:r>
+              <a:rPr sz="950" b="0" lang="zh-CN">
+                <a:solidFill>
+                  <a:srgbClr val="000000"/>
+                </a:solidFill>
+                <a:latin typeface="Arial"/>
+                <a:ea typeface="Arial"/>
+                <a:cs typeface="Arial"/>
+              </a:rPr>
+              <a:t>₈</a:t>
+            </a:r>
+            <a:r>
+              <a:rPr sz="950" b="0" lang="zh-CN">
+                <a:solidFill>
+                  <a:srgbClr val="000000"/>
+                </a:solidFill>
+                <a:latin typeface="Microsoft YaHei"/>
+                <a:ea typeface="Microsoft YaHei"/>
+                <a:cs typeface="Microsoft YaHei"/>
+              </a:rPr>
+              <a:t>固定；周边虹膜切</a:t>
             </a:r>
           </a:p>
           <a:p>
@@ -6874,7 +7006,7 @@
                 <a:ea typeface="Microsoft YaHei"/>
                 <a:cs typeface="Microsoft YaHei"/>
               </a:rPr>
-              <a:t>切除防阻滞。DMEK不能黏弹剂固定。</a:t>
+              <a:t>除防阻滞。DMEK不能使用黏弹剂固定。</a:t>
             </a:r>
           </a:p>
         </p:txBody>
@@ -7860,7 +7992,7 @@
       </p:sp>
       <p:sp>
         <p:nvSpPr>
-          <p:cNvPr id="79" name="辨方向、减少接触；空气或10%~14% C3F8固定；周边虹膜切除防阻滞。DMEK不能黏弹剂固定。"/>
+          <p:cNvPr id="79" name="辨方向、减少接触；空气或10%~14% C₃F₈固定；周边虹膜切除防阻滞。DMEK不能使用黏弹剂固定"/>
           <p:cNvSpPr txBox="1"/>
           <p:nvPr/>
         </p:nvSpPr>
@@ -7900,7 +8032,51 @@
                 <a:ea typeface="Microsoft YaHei"/>
                 <a:cs typeface="Microsoft YaHei"/>
               </a:rPr>
-              <a:t>辨方向、减少接触；空气或10%~14% C3F8固定；周边虹膜</a:t>
+              <a:t>辨方向、减少接触；空气或10%~14% C</a:t>
+            </a:r>
+            <a:r>
+              <a:rPr sz="950" b="0" lang="zh-CN">
+                <a:solidFill>
+                  <a:srgbClr val="000000"/>
+                </a:solidFill>
+                <a:latin typeface="Arial"/>
+                <a:ea typeface="Arial"/>
+                <a:cs typeface="Arial"/>
+              </a:rPr>
+              <a:t>₃</a:t>
+            </a:r>
+            <a:r>
+              <a:rPr sz="950" b="0" lang="zh-CN">
+                <a:solidFill>
+                  <a:srgbClr val="000000"/>
+                </a:solidFill>
+                <a:latin typeface="Microsoft YaHei"/>
+                <a:ea typeface="Microsoft YaHei"/>
+                <a:cs typeface="Microsoft YaHei"/>
+              </a:rPr>
+              <a:t>F</a:t>
+            </a:r>
+            <a:r>
+              <a:rPr sz="950" b="0" lang="zh-CN">
+                <a:solidFill>
+                  <a:srgbClr val="000000"/>
+                </a:solidFill>
+                <a:latin typeface="Arial"/>
+                <a:ea typeface="Arial"/>
+                <a:cs typeface="Arial"/>
+              </a:rPr>
+              <a:t>₈</a:t>
+            </a:r>
+            <a:r>
+              <a:rPr sz="950" b="0" lang="zh-CN">
+                <a:solidFill>
+                  <a:srgbClr val="000000"/>
+                </a:solidFill>
+                <a:latin typeface="Microsoft YaHei"/>
+                <a:ea typeface="Microsoft YaHei"/>
+                <a:cs typeface="Microsoft YaHei"/>
+              </a:rPr>
+              <a:t>固定；周边虹膜切</a:t>
             </a:r>
           </a:p>
           <a:p>
@@ -7924,7 +8100,7 @@
                 <a:ea typeface="Microsoft YaHei"/>
                 <a:cs typeface="Microsoft YaHei"/>
               </a:rPr>
-              <a:t>切除防阻滞。DMEK不能黏弹剂固定。</a:t>
+              <a:t>除防阻滞。DMEK不能使用黏弹剂固定。</a:t>
             </a:r>
           </a:p>
         </p:txBody>
@@ -8446,7 +8622,7 @@
       </p:sp>
       <p:sp>
         <p:nvSpPr>
-          <p:cNvPr id="7" name="DSEK&gt;1/3或DMEK&gt;1/4面积再注气；&lt;1/4可观察，扩大/水肿不退再注。DSEK中间区间及"/>
+          <p:cNvPr id="7" name="DSEK脱离&gt;1/3或DMEK脱离&gt;1/4面积再注气；&lt;1/4可观察，扩大/水肿不退再注。DSEK中"/>
           <p:cNvSpPr txBox="1"/>
           <p:nvPr/>
         </p:nvSpPr>
@@ -8486,7 +8662,7 @@
                 <a:ea typeface="Microsoft YaHei"/>
                 <a:cs typeface="Microsoft YaHei"/>
               </a:rPr>
-              <a:t>DSEK&gt;1/3或DMEK&gt;1/4面积再注气；&lt;1/4可观察，扩大/水</a:t>
+              <a:t>DSEK脱离&gt;1/3或DMEK脱离&gt;1/4面积再注气；&lt;1/4可观察，</a:t>
             </a:r>
           </a:p>
           <a:p>
@@ -8510,7 +8686,7 @@
                 <a:ea typeface="Microsoft YaHei"/>
                 <a:cs typeface="Microsoft YaHei"/>
               </a:rPr>
-              <a:t>肿不退再注。DSEK中间区间及边界原文未明确。</a:t>
+              <a:t>扩大/水肿不退再注。DSEK中间区间及边界原文未明确。</a:t>
             </a:r>
           </a:p>
         </p:txBody>
@@ -8866,7 +9042,7 @@
       </p:sp>
       <p:sp>
         <p:nvSpPr>
-          <p:cNvPr id="15" name="保持24 h足量气体，坐位避开6:00虹膜切除口；可疑脱离做前节OCT；透明后尽早内皮计数、定期复查"/>
+          <p:cNvPr id="15" name="保持24 h足量气体，坐位避开6点钟方位虹膜切除口；可疑脱离做前节OCT；透明后尽早内皮计数、定期复"/>
           <p:cNvSpPr txBox="1"/>
           <p:nvPr/>
         </p:nvSpPr>
@@ -8906,7 +9082,7 @@
                 <a:ea typeface="Microsoft YaHei"/>
                 <a:cs typeface="Microsoft YaHei"/>
               </a:rPr>
-              <a:t>保持24 h足量气体，坐位避开6:00虹膜切除口；可疑脱离做</a:t>
+              <a:t>保持24 h足量气体，坐位避开6点钟方位虹膜切除口；可疑脱</a:t>
             </a:r>
           </a:p>
           <a:p>
@@ -8930,7 +9106,7 @@
                 <a:ea typeface="Microsoft YaHei"/>
                 <a:cs typeface="Microsoft YaHei"/>
               </a:rPr>
-              <a:t>前节OCT；透明后尽早内皮计数、定期复查。</a:t>
+              <a:t>离做前节OCT；透明后尽早内皮计数、定期复查。</a:t>
             </a:r>
           </a:p>
         </p:txBody>
@@ -9496,7 +9672,7 @@
       </p:sp>
       <p:sp>
         <p:nvSpPr>
-          <p:cNvPr id="27" name="DSEK&gt;1/3或DMEK&gt;1/4面积再注气；&lt;1/4可观察，扩大/水肿不退再注。DSEK中间区间及"/>
+          <p:cNvPr id="27" name="DSEK脱离&gt;1/3或DMEK脱离&gt;1/4面积再注气；&lt;1/4可观察，扩大/水肿不退再注。DSEK中"/>
           <p:cNvSpPr txBox="1"/>
           <p:nvPr/>
         </p:nvSpPr>
@@ -9536,7 +9712,7 @@
                 <a:ea typeface="Microsoft YaHei"/>
                 <a:cs typeface="Microsoft YaHei"/>
               </a:rPr>
-              <a:t>DSEK&gt;1/3或DMEK&gt;1/4面积再注气；&lt;1/4可观察，扩大/水</a:t>
+              <a:t>DSEK脱离&gt;1/3或DMEK脱离&gt;1/4面积再注气；&lt;1/4可观察，</a:t>
             </a:r>
           </a:p>
           <a:p>
@@ -9560,7 +9736,7 @@
                 <a:ea typeface="Microsoft YaHei"/>
                 <a:cs typeface="Microsoft YaHei"/>
               </a:rPr>
-              <a:t>肿不退再注。DSEK中间区间及边界原文未明确。</a:t>
+              <a:t>扩大/水肿不退再注。DSEK中间区间及边界原文未明确。</a:t>
             </a:r>
           </a:p>
         </p:txBody>
@@ -9916,7 +10092,7 @@
       </p:sp>
       <p:sp>
         <p:nvSpPr>
-          <p:cNvPr id="35" name="保持24 h足量气体，坐位避开6:00虹膜切除口；可疑脱离做前节OCT；透明后尽早内皮计数、定期复查"/>
+          <p:cNvPr id="35" name="保持24 h足量气体，坐位避开6点钟方位虹膜切除口；可疑脱离做前节OCT；透明后尽早内皮计数、定期复"/>
           <p:cNvSpPr txBox="1"/>
           <p:nvPr/>
         </p:nvSpPr>
@@ -9956,7 +10132,7 @@
                 <a:ea typeface="Microsoft YaHei"/>
                 <a:cs typeface="Microsoft YaHei"/>
               </a:rPr>
-              <a:t>保持24 h足量气体，坐位避开6:00虹膜切除口；可疑脱离做</a:t>
+              <a:t>保持24 h足量气体，坐位避开6点钟方位虹膜切除口；可疑脱</a:t>
             </a:r>
           </a:p>
           <a:p>
@@ -9980,7 +10156,7 @@
                 <a:ea typeface="Microsoft YaHei"/>
                 <a:cs typeface="Microsoft YaHei"/>
               </a:rPr>
-              <a:t>前节OCT；透明后尽早内皮计数、定期复查。</a:t>
+              <a:t>离做前节OCT；透明后尽早内皮计数、定期复查。</a:t>
             </a:r>
           </a:p>
         </p:txBody>
@@ -10546,7 +10722,7 @@
       </p:sp>
       <p:sp>
         <p:nvSpPr>
-          <p:cNvPr id="47" name="DSEK&gt;1/3或DMEK&gt;1/4面积再注气；&lt;1/4可观察，扩大/水肿不退再注。DSEK中间区间及"/>
+          <p:cNvPr id="47" name="DSEK脱离&gt;1/3或DMEK脱离&gt;1/4面积再注气；&lt;1/4可观察，扩大/水肿不退再注。DSEK中"/>
           <p:cNvSpPr txBox="1"/>
           <p:nvPr/>
         </p:nvSpPr>
@@ -10586,7 +10762,7 @@
                 <a:ea typeface="Microsoft YaHei"/>
                 <a:cs typeface="Microsoft YaHei"/>
               </a:rPr>
-              <a:t>DSEK&gt;1/3或DMEK&gt;1/4面积再注气；&lt;1/4可观察，扩大/水</a:t>
+              <a:t>DSEK脱离&gt;1/3或DMEK脱离&gt;1/4面积再注气；&lt;1/4可观察，</a:t>
             </a:r>
           </a:p>
           <a:p>
@@ -10610,7 +10786,7 @@
                 <a:ea typeface="Microsoft YaHei"/>
                 <a:cs typeface="Microsoft YaHei"/>
               </a:rPr>
-              <a:t>肿不退再注。DSEK中间区间及边界原文未明确。</a:t>
+              <a:t>扩大/水肿不退再注。DSEK中间区间及边界原文未明确。</a:t>
             </a:r>
           </a:p>
         </p:txBody>
@@ -10966,7 +11142,7 @@
       </p:sp>
       <p:sp>
         <p:nvSpPr>
-          <p:cNvPr id="55" name="保持24 h足量气体，坐位避开6:00虹膜切除口；可疑脱离做前节OCT；透明后尽早内皮计数、定期复查"/>
+          <p:cNvPr id="55" name="保持24 h足量气体，坐位避开6点钟方位虹膜切除口；可疑脱离做前节OCT；透明后尽早内皮计数、定期复"/>
           <p:cNvSpPr txBox="1"/>
           <p:nvPr/>
         </p:nvSpPr>
@@ -11006,7 +11182,7 @@
                 <a:ea typeface="Microsoft YaHei"/>
                 <a:cs typeface="Microsoft YaHei"/>
               </a:rPr>
-              <a:t>保持24 h足量气体，坐位避开6:00虹膜切除口；可疑脱离做</a:t>
+              <a:t>保持24 h足量气体，坐位避开6点钟方位虹膜切除口；可疑脱</a:t>
             </a:r>
           </a:p>
           <a:p>
@@ -11030,7 +11206,7 @@
                 <a:ea typeface="Microsoft YaHei"/>
                 <a:cs typeface="Microsoft YaHei"/>
               </a:rPr>
-              <a:t>前节OCT；透明后尽早内皮计数、定期复查。</a:t>
+              <a:t>离做前节OCT；透明后尽早内皮计数、定期复查。</a:t>
             </a:r>
           </a:p>
         </p:txBody>
@@ -11596,7 +11772,7 @@
       </p:sp>
       <p:sp>
         <p:nvSpPr>
-          <p:cNvPr id="67" name="DSEK&gt;1/3或DMEK&gt;1/4面积再注气；&lt;1/4可观察，扩大/水肿不退再注。DSEK中间区间及"/>
+          <p:cNvPr id="67" name="DSEK脱离&gt;1/3或DMEK脱离&gt;1/4面积再注气；&lt;1/4可观察，扩大/水肿不退再注。DSEK中"/>
           <p:cNvSpPr txBox="1"/>
           <p:nvPr/>
         </p:nvSpPr>
@@ -11636,7 +11812,7 @@
                 <a:ea typeface="Microsoft YaHei"/>
                 <a:cs typeface="Microsoft YaHei"/>
               </a:rPr>
-              <a:t>DSEK&gt;1/3或DMEK&gt;1/4面积再注气；&lt;1/4可观察，扩大/水</a:t>
+              <a:t>DSEK脱离&gt;1/3或DMEK脱离&gt;1/4面积再注气；&lt;1/4可观察，</a:t>
             </a:r>
           </a:p>
           <a:p>
@@ -11660,7 +11836,7 @@
                 <a:ea typeface="Microsoft YaHei"/>
                 <a:cs typeface="Microsoft YaHei"/>
               </a:rPr>
-              <a:t>肿不退再注。DSEK中间区间及边界原文未明确。</a:t>
+              <a:t>扩大/水肿不退再注。DSEK中间区间及边界原文未明确。</a:t>
             </a:r>
           </a:p>
         </p:txBody>
@@ -12016,7 +12192,7 @@
       </p:sp>
       <p:sp>
         <p:nvSpPr>
-          <p:cNvPr id="75" name="保持24 h足量气体，坐位避开6:00虹膜切除口；可疑脱离做前节OCT；透明后尽早内皮计数、定期复查"/>
+          <p:cNvPr id="75" name="保持24 h足量气体，坐位避开6点钟方位虹膜切除口；可疑脱离做前节OCT；透明后尽早内皮计数、定期复"/>
           <p:cNvSpPr txBox="1"/>
           <p:nvPr/>
         </p:nvSpPr>
@@ -12056,7 +12232,7 @@
                 <a:ea typeface="Microsoft YaHei"/>
                 <a:cs typeface="Microsoft YaHei"/>
               </a:rPr>
-              <a:t>保持24 h足量气体，坐位避开6:00虹膜切除口；可疑脱离做</a:t>
+              <a:t>保持24 h足量气体，坐位避开6点钟方位虹膜切除口；可疑脱</a:t>
             </a:r>
           </a:p>
           <a:p>
@@ -12080,7 +12256,7 @@
                 <a:ea typeface="Microsoft YaHei"/>
                 <a:cs typeface="Microsoft YaHei"/>
               </a:rPr>
-              <a:t>前节OCT；透明后尽早内皮计数、定期复查。</a:t>
+              <a:t>离做前节OCT；透明后尽早内皮计数、定期复查。</a:t>
             </a:r>
           </a:p>
         </p:txBody>

</xml_diff>